<commit_message>
datatable: update modified date
</commit_message>
<xml_diff>
--- a/powerpoints/datatable.pptx
+++ b/powerpoints/datatable.pptx
@@ -418,7 +418,7 @@
           <a:p>
             <a:fld id="{14A1A45B-F66E-48A2-89C5-3AD170776287}" type="datetimeFigureOut">
               <a:rPr lang="da-DK" smtClean="0"/>
-              <a:t>22.07.2026</a:t>
+              <a:t>29.07.2026</a:t>
             </a:fld>
             <a:endParaRPr lang="da-DK"/>
           </a:p>
@@ -2444,7 +2444,7 @@
           </a:ln>
           <a:extLst>
             <a:ext uri="{C572A759-6A51-4108-AA02-DFA0A04FC94B}">
-              <ma14:wrappingTextBoxFlag xmlns:ma14="http://schemas.microsoft.com/office/mac/drawingml/2011/main" xmlns="" val="1"/>
+              <ma14:wrappingTextBoxFlag xmlns="" xmlns:ma14="http://schemas.microsoft.com/office/mac/drawingml/2011/main" val="1"/>
             </a:ext>
           </a:extLst>
         </p:spPr>
@@ -2483,7 +2483,7 @@
           </a:ln>
           <a:extLst>
             <a:ext uri="{C572A759-6A51-4108-AA02-DFA0A04FC94B}">
-              <ma14:wrappingTextBoxFlag xmlns:ma14="http://schemas.microsoft.com/office/mac/drawingml/2011/main" xmlns="" val="1"/>
+              <ma14:wrappingTextBoxFlag xmlns="" xmlns:ma14="http://schemas.microsoft.com/office/mac/drawingml/2011/main" val="1"/>
             </a:ext>
           </a:extLst>
         </p:spPr>
@@ -3540,7 +3540,7 @@
           </a:ln>
           <a:extLst>
             <a:ext uri="{C572A759-6A51-4108-AA02-DFA0A04FC94B}">
-              <ma14:wrappingTextBoxFlag xmlns:ma14="http://schemas.microsoft.com/office/mac/drawingml/2011/main" xmlns="" val="1"/>
+              <ma14:wrappingTextBoxFlag xmlns="" xmlns:ma14="http://schemas.microsoft.com/office/mac/drawingml/2011/main" val="1"/>
             </a:ext>
           </a:extLst>
         </p:spPr>
@@ -3759,7 +3759,7 @@
           </a:ln>
           <a:extLst>
             <a:ext uri="{C572A759-6A51-4108-AA02-DFA0A04FC94B}">
-              <ma14:wrappingTextBoxFlag xmlns:ma14="http://schemas.microsoft.com/office/mac/drawingml/2011/main" xmlns="" val="1"/>
+              <ma14:wrappingTextBoxFlag xmlns="" xmlns:ma14="http://schemas.microsoft.com/office/mac/drawingml/2011/main" val="1"/>
             </a:ext>
           </a:extLst>
         </p:spPr>
@@ -3820,7 +3820,7 @@
           </a:ln>
           <a:extLst>
             <a:ext uri="{C572A759-6A51-4108-AA02-DFA0A04FC94B}">
-              <ma14:wrappingTextBoxFlag xmlns:ma14="http://schemas.microsoft.com/office/mac/drawingml/2011/main" xmlns="" val="1"/>
+              <ma14:wrappingTextBoxFlag xmlns="" xmlns:ma14="http://schemas.microsoft.com/office/mac/drawingml/2011/main" val="1"/>
             </a:ext>
           </a:extLst>
         </p:spPr>
@@ -3873,7 +3873,7 @@
           </a:ln>
           <a:extLst>
             <a:ext uri="{C572A759-6A51-4108-AA02-DFA0A04FC94B}">
-              <ma14:wrappingTextBoxFlag xmlns:ma14="http://schemas.microsoft.com/office/mac/drawingml/2011/main" xmlns="" val="1"/>
+              <ma14:wrappingTextBoxFlag xmlns="" xmlns:ma14="http://schemas.microsoft.com/office/mac/drawingml/2011/main" val="1"/>
             </a:ext>
           </a:extLst>
         </p:spPr>
@@ -4262,7 +4262,7 @@
           </a:ln>
           <a:extLst>
             <a:ext uri="{C572A759-6A51-4108-AA02-DFA0A04FC94B}">
-              <ma14:wrappingTextBoxFlag xmlns:ma14="http://schemas.microsoft.com/office/mac/drawingml/2011/main" xmlns="" val="1"/>
+              <ma14:wrappingTextBoxFlag xmlns="" xmlns:ma14="http://schemas.microsoft.com/office/mac/drawingml/2011/main" val="1"/>
             </a:ext>
           </a:extLst>
         </p:spPr>
@@ -4504,7 +4504,7 @@
           </a:ln>
           <a:extLst>
             <a:ext uri="{C572A759-6A51-4108-AA02-DFA0A04FC94B}">
-              <ma14:wrappingTextBoxFlag xmlns:ma14="http://schemas.microsoft.com/office/mac/drawingml/2011/main" xmlns="" val="1"/>
+              <ma14:wrappingTextBoxFlag xmlns="" xmlns:ma14="http://schemas.microsoft.com/office/mac/drawingml/2011/main" val="1"/>
             </a:ext>
           </a:extLst>
         </p:spPr>
@@ -4602,7 +4602,7 @@
           </a:ln>
           <a:extLst>
             <a:ext uri="{C572A759-6A51-4108-AA02-DFA0A04FC94B}">
-              <ma14:wrappingTextBoxFlag xmlns:ma14="http://schemas.microsoft.com/office/mac/drawingml/2011/main" xmlns="" val="1"/>
+              <ma14:wrappingTextBoxFlag xmlns="" xmlns:ma14="http://schemas.microsoft.com/office/mac/drawingml/2011/main" val="1"/>
             </a:ext>
           </a:extLst>
         </p:spPr>
@@ -4871,7 +4871,7 @@
           </a:ln>
           <a:extLst>
             <a:ext uri="{C572A759-6A51-4108-AA02-DFA0A04FC94B}">
-              <ma14:wrappingTextBoxFlag xmlns:ma14="http://schemas.microsoft.com/office/mac/drawingml/2011/main" xmlns="" val="1"/>
+              <ma14:wrappingTextBoxFlag xmlns="" xmlns:ma14="http://schemas.microsoft.com/office/mac/drawingml/2011/main" val="1"/>
             </a:ext>
           </a:extLst>
         </p:spPr>
@@ -4977,7 +4977,7 @@
           </a:ln>
           <a:extLst>
             <a:ext uri="{C572A759-6A51-4108-AA02-DFA0A04FC94B}">
-              <ma14:wrappingTextBoxFlag xmlns:ma14="http://schemas.microsoft.com/office/mac/drawingml/2011/main" xmlns="" val="1"/>
+              <ma14:wrappingTextBoxFlag xmlns="" xmlns:ma14="http://schemas.microsoft.com/office/mac/drawingml/2011/main" val="1"/>
             </a:ext>
           </a:extLst>
         </p:spPr>
@@ -5069,7 +5069,7 @@
           </a:ln>
           <a:extLst>
             <a:ext uri="{C572A759-6A51-4108-AA02-DFA0A04FC94B}">
-              <ma14:wrappingTextBoxFlag xmlns:ma14="http://schemas.microsoft.com/office/mac/drawingml/2011/main" xmlns="" val="1"/>
+              <ma14:wrappingTextBoxFlag xmlns="" xmlns:ma14="http://schemas.microsoft.com/office/mac/drawingml/2011/main" val="1"/>
             </a:ext>
           </a:extLst>
         </p:spPr>
@@ -5844,7 +5844,7 @@
           </a:ln>
           <a:extLst>
             <a:ext uri="{C572A759-6A51-4108-AA02-DFA0A04FC94B}">
-              <ma14:wrappingTextBoxFlag xmlns:ma14="http://schemas.microsoft.com/office/mac/drawingml/2011/main" xmlns="" val="1"/>
+              <ma14:wrappingTextBoxFlag xmlns="" xmlns:ma14="http://schemas.microsoft.com/office/mac/drawingml/2011/main" val="1"/>
             </a:ext>
           </a:extLst>
         </p:spPr>
@@ -6491,7 +6491,7 @@
           </a:ln>
           <a:extLst>
             <a:ext uri="{C572A759-6A51-4108-AA02-DFA0A04FC94B}">
-              <ma14:wrappingTextBoxFlag xmlns:ma14="http://schemas.microsoft.com/office/mac/drawingml/2011/main" xmlns="" val="1"/>
+              <ma14:wrappingTextBoxFlag xmlns="" xmlns:ma14="http://schemas.microsoft.com/office/mac/drawingml/2011/main" val="1"/>
             </a:ext>
           </a:extLst>
         </p:spPr>
@@ -8017,7 +8017,7 @@
           </a:ln>
           <a:extLst>
             <a:ext uri="{C572A759-6A51-4108-AA02-DFA0A04FC94B}">
-              <ma14:wrappingTextBoxFlag xmlns:ma14="http://schemas.microsoft.com/office/mac/drawingml/2011/main" xmlns="" val="1"/>
+              <ma14:wrappingTextBoxFlag xmlns="" xmlns:ma14="http://schemas.microsoft.com/office/mac/drawingml/2011/main" val="1"/>
             </a:ext>
           </a:extLst>
         </p:spPr>
@@ -8182,7 +8182,7 @@
           </a:ln>
           <a:extLst>
             <a:ext uri="{C572A759-6A51-4108-AA02-DFA0A04FC94B}">
-              <ma14:wrappingTextBoxFlag xmlns:ma14="http://schemas.microsoft.com/office/mac/drawingml/2011/main" xmlns="" val="1"/>
+              <ma14:wrappingTextBoxFlag xmlns="" xmlns:ma14="http://schemas.microsoft.com/office/mac/drawingml/2011/main" val="1"/>
             </a:ext>
           </a:extLst>
         </p:spPr>
@@ -9359,7 +9359,7 @@
           </a:ln>
           <a:extLst>
             <a:ext uri="{C572A759-6A51-4108-AA02-DFA0A04FC94B}">
-              <ma14:wrappingTextBoxFlag xmlns:ma14="http://schemas.microsoft.com/office/mac/drawingml/2011/main" xmlns="" val="1"/>
+              <ma14:wrappingTextBoxFlag xmlns="" xmlns:ma14="http://schemas.microsoft.com/office/mac/drawingml/2011/main" val="1"/>
             </a:ext>
           </a:extLst>
         </p:spPr>
@@ -9455,7 +9455,7 @@
           </a:ln>
           <a:extLst>
             <a:ext uri="{C572A759-6A51-4108-AA02-DFA0A04FC94B}">
-              <ma14:wrappingTextBoxFlag xmlns:ma14="http://schemas.microsoft.com/office/mac/drawingml/2011/main" xmlns="" val="1"/>
+              <ma14:wrappingTextBoxFlag xmlns="" xmlns:ma14="http://schemas.microsoft.com/office/mac/drawingml/2011/main" val="1"/>
             </a:ext>
           </a:extLst>
         </p:spPr>
@@ -10851,7 +10851,7 @@
           </a:ln>
           <a:extLst>
             <a:ext uri="{C572A759-6A51-4108-AA02-DFA0A04FC94B}">
-              <ma14:wrappingTextBoxFlag xmlns:ma14="http://schemas.microsoft.com/office/mac/drawingml/2011/main" xmlns="" val="1"/>
+              <ma14:wrappingTextBoxFlag xmlns="" xmlns:ma14="http://schemas.microsoft.com/office/mac/drawingml/2011/main" val="1"/>
             </a:ext>
           </a:extLst>
         </p:spPr>
@@ -11957,7 +11957,7 @@
           </a:ln>
           <a:extLst>
             <a:ext uri="{C572A759-6A51-4108-AA02-DFA0A04FC94B}">
-              <ma14:wrappingTextBoxFlag xmlns:ma14="http://schemas.microsoft.com/office/mac/drawingml/2011/main" xmlns="" val="1"/>
+              <ma14:wrappingTextBoxFlag xmlns="" xmlns:ma14="http://schemas.microsoft.com/office/mac/drawingml/2011/main" val="1"/>
             </a:ext>
           </a:extLst>
         </p:spPr>
@@ -13793,7 +13793,7 @@
           </a:ln>
           <a:extLst>
             <a:ext uri="{C572A759-6A51-4108-AA02-DFA0A04FC94B}">
-              <ma14:wrappingTextBoxFlag xmlns:ma14="http://schemas.microsoft.com/office/mac/drawingml/2011/main" xmlns="" val="1"/>
+              <ma14:wrappingTextBoxFlag xmlns="" xmlns:ma14="http://schemas.microsoft.com/office/mac/drawingml/2011/main" val="1"/>
             </a:ext>
           </a:extLst>
         </p:spPr>
@@ -14091,7 +14091,7 @@
           </a:ln>
           <a:extLst>
             <a:ext uri="{C572A759-6A51-4108-AA02-DFA0A04FC94B}">
-              <ma14:wrappingTextBoxFlag xmlns:ma14="http://schemas.microsoft.com/office/mac/drawingml/2011/main" xmlns="" val="1"/>
+              <ma14:wrappingTextBoxFlag xmlns="" xmlns:ma14="http://schemas.microsoft.com/office/mac/drawingml/2011/main" val="1"/>
             </a:ext>
           </a:extLst>
         </p:spPr>
@@ -14150,7 +14150,7 @@
           </a:ln>
           <a:extLst>
             <a:ext uri="{C572A759-6A51-4108-AA02-DFA0A04FC94B}">
-              <ma14:wrappingTextBoxFlag xmlns:ma14="http://schemas.microsoft.com/office/mac/drawingml/2011/main" xmlns="" val="1"/>
+              <ma14:wrappingTextBoxFlag xmlns="" xmlns:ma14="http://schemas.microsoft.com/office/mac/drawingml/2011/main" val="1"/>
             </a:ext>
           </a:extLst>
         </p:spPr>
@@ -14344,7 +14344,7 @@
           </a:ln>
           <a:extLst>
             <a:ext uri="{C572A759-6A51-4108-AA02-DFA0A04FC94B}">
-              <ma14:wrappingTextBoxFlag xmlns:ma14="http://schemas.microsoft.com/office/mac/drawingml/2011/main" xmlns="" val="1"/>
+              <ma14:wrappingTextBoxFlag xmlns="" xmlns:ma14="http://schemas.microsoft.com/office/mac/drawingml/2011/main" val="1"/>
             </a:ext>
           </a:extLst>
         </p:spPr>
@@ -15111,7 +15111,7 @@
           </a:ln>
           <a:extLst>
             <a:ext uri="{C572A759-6A51-4108-AA02-DFA0A04FC94B}">
-              <ma14:wrappingTextBoxFlag xmlns:ma14="http://schemas.microsoft.com/office/mac/drawingml/2011/main" xmlns="" val="1"/>
+              <ma14:wrappingTextBoxFlag xmlns="" xmlns:ma14="http://schemas.microsoft.com/office/mac/drawingml/2011/main" val="1"/>
             </a:ext>
           </a:extLst>
         </p:spPr>
@@ -15854,7 +15854,7 @@
           </a:ln>
           <a:extLst>
             <a:ext uri="{C572A759-6A51-4108-AA02-DFA0A04FC94B}">
-              <ma14:wrappingTextBoxFlag xmlns:ma14="http://schemas.microsoft.com/office/mac/drawingml/2011/main" xmlns="" val="1"/>
+              <ma14:wrappingTextBoxFlag xmlns="" xmlns:ma14="http://schemas.microsoft.com/office/mac/drawingml/2011/main" val="1"/>
             </a:ext>
           </a:extLst>
         </p:spPr>
@@ -16552,7 +16552,7 @@
           </a:ln>
           <a:extLst>
             <a:ext uri="{C572A759-6A51-4108-AA02-DFA0A04FC94B}">
-              <ma14:wrappingTextBoxFlag xmlns:ma14="http://schemas.microsoft.com/office/mac/drawingml/2011/main" xmlns="" val="1"/>
+              <ma14:wrappingTextBoxFlag xmlns="" xmlns:ma14="http://schemas.microsoft.com/office/mac/drawingml/2011/main" val="1"/>
             </a:ext>
           </a:extLst>
         </p:spPr>
@@ -16654,7 +16654,7 @@
           </a:ln>
           <a:extLst>
             <a:ext uri="{C572A759-6A51-4108-AA02-DFA0A04FC94B}">
-              <ma14:wrappingTextBoxFlag xmlns:ma14="http://schemas.microsoft.com/office/mac/drawingml/2011/main" xmlns="" val="1"/>
+              <ma14:wrappingTextBoxFlag xmlns="" xmlns:ma14="http://schemas.microsoft.com/office/mac/drawingml/2011/main" val="1"/>
             </a:ext>
           </a:extLst>
         </p:spPr>
@@ -16857,7 +16857,7 @@
                   <a:srgbClr val="5B6167"/>
                 </a:solidFill>
               </a:rPr>
-              <a:t>25</a:t>
+              <a:t>26</a:t>
             </a:r>
             <a:r>
               <a:rPr dirty="0">
@@ -17086,7 +17086,7 @@
           </a:ln>
           <a:extLst>
             <a:ext uri="{C572A759-6A51-4108-AA02-DFA0A04FC94B}">
-              <ma14:wrappingTextBoxFlag xmlns:ma14="http://schemas.microsoft.com/office/mac/drawingml/2011/main" xmlns="" val="1"/>
+              <ma14:wrappingTextBoxFlag xmlns="" xmlns:ma14="http://schemas.microsoft.com/office/mac/drawingml/2011/main" val="1"/>
             </a:ext>
           </a:extLst>
         </p:spPr>
@@ -17184,7 +17184,7 @@
           </a:ln>
           <a:extLst>
             <a:ext uri="{C572A759-6A51-4108-AA02-DFA0A04FC94B}">
-              <ma14:wrappingTextBoxFlag xmlns:ma14="http://schemas.microsoft.com/office/mac/drawingml/2011/main" xmlns="" val="1"/>
+              <ma14:wrappingTextBoxFlag xmlns="" xmlns:ma14="http://schemas.microsoft.com/office/mac/drawingml/2011/main" val="1"/>
             </a:ext>
           </a:extLst>
         </p:spPr>
@@ -17237,7 +17237,7 @@
           </a:ln>
           <a:extLst>
             <a:ext uri="{C572A759-6A51-4108-AA02-DFA0A04FC94B}">
-              <ma14:wrappingTextBoxFlag xmlns:ma14="http://schemas.microsoft.com/office/mac/drawingml/2011/main" xmlns="" val="1"/>
+              <ma14:wrappingTextBoxFlag xmlns="" xmlns:ma14="http://schemas.microsoft.com/office/mac/drawingml/2011/main" val="1"/>
             </a:ext>
           </a:extLst>
         </p:spPr>
@@ -18147,7 +18147,7 @@
           </a:ln>
           <a:extLst>
             <a:ext uri="{C572A759-6A51-4108-AA02-DFA0A04FC94B}">
-              <ma14:wrappingTextBoxFlag xmlns:ma14="http://schemas.microsoft.com/office/mac/drawingml/2011/main" xmlns="" val="1"/>
+              <ma14:wrappingTextBoxFlag xmlns="" xmlns:ma14="http://schemas.microsoft.com/office/mac/drawingml/2011/main" val="1"/>
             </a:ext>
           </a:extLst>
         </p:spPr>
@@ -18653,7 +18653,7 @@
           </a:ln>
           <a:extLst>
             <a:ext uri="{C572A759-6A51-4108-AA02-DFA0A04FC94B}">
-              <ma14:wrappingTextBoxFlag xmlns:ma14="http://schemas.microsoft.com/office/mac/drawingml/2011/main" xmlns="" val="1"/>
+              <ma14:wrappingTextBoxFlag xmlns="" xmlns:ma14="http://schemas.microsoft.com/office/mac/drawingml/2011/main" val="1"/>
             </a:ext>
           </a:extLst>
         </p:spPr>
@@ -18698,7 +18698,7 @@
           </a:ln>
           <a:extLst>
             <a:ext uri="{C572A759-6A51-4108-AA02-DFA0A04FC94B}">
-              <ma14:wrappingTextBoxFlag xmlns:ma14="http://schemas.microsoft.com/office/mac/drawingml/2011/main" xmlns="" val="1"/>
+              <ma14:wrappingTextBoxFlag xmlns="" xmlns:ma14="http://schemas.microsoft.com/office/mac/drawingml/2011/main" val="1"/>
             </a:ext>
           </a:extLst>
         </p:spPr>
@@ -19771,7 +19771,7 @@
           </a:ln>
           <a:extLst>
             <a:ext uri="{C572A759-6A51-4108-AA02-DFA0A04FC94B}">
-              <ma14:wrappingTextBoxFlag xmlns:ma14="http://schemas.microsoft.com/office/mac/drawingml/2011/main" xmlns="" val="1"/>
+              <ma14:wrappingTextBoxFlag xmlns="" xmlns:ma14="http://schemas.microsoft.com/office/mac/drawingml/2011/main" val="1"/>
             </a:ext>
           </a:extLst>
         </p:spPr>
@@ -20420,7 +20420,7 @@
           </a:ln>
           <a:extLst>
             <a:ext uri="{C572A759-6A51-4108-AA02-DFA0A04FC94B}">
-              <ma14:wrappingTextBoxFlag xmlns:ma14="http://schemas.microsoft.com/office/mac/drawingml/2011/main" xmlns="" val="1"/>
+              <ma14:wrappingTextBoxFlag xmlns="" xmlns:ma14="http://schemas.microsoft.com/office/mac/drawingml/2011/main" val="1"/>
             </a:ext>
           </a:extLst>
         </p:spPr>
@@ -20465,7 +20465,7 @@
           </a:ln>
           <a:extLst>
             <a:ext uri="{C572A759-6A51-4108-AA02-DFA0A04FC94B}">
-              <ma14:wrappingTextBoxFlag xmlns:ma14="http://schemas.microsoft.com/office/mac/drawingml/2011/main" xmlns="" val="1"/>
+              <ma14:wrappingTextBoxFlag xmlns="" xmlns:ma14="http://schemas.microsoft.com/office/mac/drawingml/2011/main" val="1"/>
             </a:ext>
           </a:extLst>
         </p:spPr>
@@ -20558,7 +20558,7 @@
           </a:ln>
           <a:extLst>
             <a:ext uri="{C572A759-6A51-4108-AA02-DFA0A04FC94B}">
-              <ma14:wrappingTextBoxFlag xmlns:ma14="http://schemas.microsoft.com/office/mac/drawingml/2011/main" xmlns="" val="1"/>
+              <ma14:wrappingTextBoxFlag xmlns="" xmlns:ma14="http://schemas.microsoft.com/office/mac/drawingml/2011/main" val="1"/>
             </a:ext>
           </a:extLst>
         </p:spPr>
@@ -21067,7 +21067,7 @@
           </a:ln>
           <a:extLst>
             <a:ext uri="{C572A759-6A51-4108-AA02-DFA0A04FC94B}">
-              <ma14:wrappingTextBoxFlag xmlns:ma14="http://schemas.microsoft.com/office/mac/drawingml/2011/main" xmlns="" val="1"/>
+              <ma14:wrappingTextBoxFlag xmlns="" xmlns:ma14="http://schemas.microsoft.com/office/mac/drawingml/2011/main" val="1"/>
             </a:ext>
           </a:extLst>
         </p:spPr>
@@ -21417,7 +21417,7 @@
           </a:ln>
           <a:extLst>
             <a:ext uri="{C572A759-6A51-4108-AA02-DFA0A04FC94B}">
-              <ma14:wrappingTextBoxFlag xmlns:ma14="http://schemas.microsoft.com/office/mac/drawingml/2011/main" xmlns="" val="1"/>
+              <ma14:wrappingTextBoxFlag xmlns="" xmlns:ma14="http://schemas.microsoft.com/office/mac/drawingml/2011/main" val="1"/>
             </a:ext>
           </a:extLst>
         </p:spPr>
@@ -21462,7 +21462,7 @@
           </a:ln>
           <a:extLst>
             <a:ext uri="{C572A759-6A51-4108-AA02-DFA0A04FC94B}">
-              <ma14:wrappingTextBoxFlag xmlns:ma14="http://schemas.microsoft.com/office/mac/drawingml/2011/main" xmlns="" val="1"/>
+              <ma14:wrappingTextBoxFlag xmlns="" xmlns:ma14="http://schemas.microsoft.com/office/mac/drawingml/2011/main" val="1"/>
             </a:ext>
           </a:extLst>
         </p:spPr>
@@ -22073,7 +22073,7 @@
           </a:ln>
           <a:extLst>
             <a:ext uri="{C572A759-6A51-4108-AA02-DFA0A04FC94B}">
-              <ma14:wrappingTextBoxFlag xmlns:ma14="http://schemas.microsoft.com/office/mac/drawingml/2011/main" xmlns="" val="1"/>
+              <ma14:wrappingTextBoxFlag xmlns="" xmlns:ma14="http://schemas.microsoft.com/office/mac/drawingml/2011/main" val="1"/>
             </a:ext>
           </a:extLst>
         </p:spPr>
@@ -22570,7 +22570,7 @@
           </a:ln>
           <a:extLst>
             <a:ext uri="{C572A759-6A51-4108-AA02-DFA0A04FC94B}">
-              <ma14:wrappingTextBoxFlag xmlns:ma14="http://schemas.microsoft.com/office/mac/drawingml/2011/main" xmlns="" val="1"/>
+              <ma14:wrappingTextBoxFlag xmlns="" xmlns:ma14="http://schemas.microsoft.com/office/mac/drawingml/2011/main" val="1"/>
             </a:ext>
           </a:extLst>
         </p:spPr>
@@ -23296,7 +23296,7 @@
           </a:ln>
           <a:extLst>
             <a:ext uri="{C572A759-6A51-4108-AA02-DFA0A04FC94B}">
-              <ma14:wrappingTextBoxFlag xmlns:ma14="http://schemas.microsoft.com/office/mac/drawingml/2011/main" xmlns="" val="1"/>
+              <ma14:wrappingTextBoxFlag xmlns="" xmlns:ma14="http://schemas.microsoft.com/office/mac/drawingml/2011/main" val="1"/>
             </a:ext>
           </a:extLst>
         </p:spPr>
@@ -23341,7 +23341,7 @@
           </a:ln>
           <a:extLst>
             <a:ext uri="{C572A759-6A51-4108-AA02-DFA0A04FC94B}">
-              <ma14:wrappingTextBoxFlag xmlns:ma14="http://schemas.microsoft.com/office/mac/drawingml/2011/main" xmlns="" val="1"/>
+              <ma14:wrappingTextBoxFlag xmlns="" xmlns:ma14="http://schemas.microsoft.com/office/mac/drawingml/2011/main" val="1"/>
             </a:ext>
           </a:extLst>
         </p:spPr>
@@ -24195,7 +24195,7 @@
           </a:ln>
           <a:extLst>
             <a:ext uri="{C572A759-6A51-4108-AA02-DFA0A04FC94B}">
-              <ma14:wrappingTextBoxFlag xmlns:ma14="http://schemas.microsoft.com/office/mac/drawingml/2011/main" xmlns="" val="1"/>
+              <ma14:wrappingTextBoxFlag xmlns="" xmlns:ma14="http://schemas.microsoft.com/office/mac/drawingml/2011/main" val="1"/>
             </a:ext>
           </a:extLst>
         </p:spPr>
@@ -24369,7 +24369,7 @@
           </a:ln>
           <a:extLst>
             <a:ext uri="{C572A759-6A51-4108-AA02-DFA0A04FC94B}">
-              <ma14:wrappingTextBoxFlag xmlns:ma14="http://schemas.microsoft.com/office/mac/drawingml/2011/main" xmlns="" val="1"/>
+              <ma14:wrappingTextBoxFlag xmlns="" xmlns:ma14="http://schemas.microsoft.com/office/mac/drawingml/2011/main" val="1"/>
             </a:ext>
           </a:extLst>
         </p:spPr>
@@ -24456,7 +24456,7 @@
           </a:ln>
           <a:extLst>
             <a:ext uri="{C572A759-6A51-4108-AA02-DFA0A04FC94B}">
-              <ma14:wrappingTextBoxFlag xmlns:ma14="http://schemas.microsoft.com/office/mac/drawingml/2011/main" xmlns="" val="1"/>
+              <ma14:wrappingTextBoxFlag xmlns="" xmlns:ma14="http://schemas.microsoft.com/office/mac/drawingml/2011/main" val="1"/>
             </a:ext>
           </a:extLst>
         </p:spPr>
@@ -24661,7 +24661,7 @@
           </a:ln>
           <a:extLst>
             <a:ext uri="{C572A759-6A51-4108-AA02-DFA0A04FC94B}">
-              <ma14:wrappingTextBoxFlag xmlns:ma14="http://schemas.microsoft.com/office/mac/drawingml/2011/main" xmlns="" val="1"/>
+              <ma14:wrappingTextBoxFlag xmlns="" xmlns:ma14="http://schemas.microsoft.com/office/mac/drawingml/2011/main" val="1"/>
             </a:ext>
           </a:extLst>
         </p:spPr>
@@ -25710,7 +25710,7 @@
           </a:ln>
           <a:extLst>
             <a:ext uri="{C572A759-6A51-4108-AA02-DFA0A04FC94B}">
-              <ma14:wrappingTextBoxFlag xmlns:ma14="http://schemas.microsoft.com/office/mac/drawingml/2011/main" xmlns="" val="1"/>
+              <ma14:wrappingTextBoxFlag xmlns="" xmlns:ma14="http://schemas.microsoft.com/office/mac/drawingml/2011/main" val="1"/>
             </a:ext>
           </a:extLst>
         </p:spPr>
@@ -25806,7 +25806,7 @@
           </a:ln>
           <a:extLst>
             <a:ext uri="{C572A759-6A51-4108-AA02-DFA0A04FC94B}">
-              <ma14:wrappingTextBoxFlag xmlns:ma14="http://schemas.microsoft.com/office/mac/drawingml/2011/main" xmlns="" val="1"/>
+              <ma14:wrappingTextBoxFlag xmlns="" xmlns:ma14="http://schemas.microsoft.com/office/mac/drawingml/2011/main" val="1"/>
             </a:ext>
           </a:extLst>
         </p:spPr>
@@ -27168,7 +27168,7 @@
           </a:ln>
           <a:extLst>
             <a:ext uri="{C572A759-6A51-4108-AA02-DFA0A04FC94B}">
-              <ma14:wrappingTextBoxFlag xmlns:ma14="http://schemas.microsoft.com/office/mac/drawingml/2011/main" xmlns="" val="1"/>
+              <ma14:wrappingTextBoxFlag xmlns="" xmlns:ma14="http://schemas.microsoft.com/office/mac/drawingml/2011/main" val="1"/>
             </a:ext>
           </a:extLst>
         </p:spPr>
@@ -27384,7 +27384,7 @@
           </a:ln>
           <a:extLst>
             <a:ext uri="{C572A759-6A51-4108-AA02-DFA0A04FC94B}">
-              <ma14:wrappingTextBoxFlag xmlns:ma14="http://schemas.microsoft.com/office/mac/drawingml/2011/main" xmlns="" val="1"/>
+              <ma14:wrappingTextBoxFlag xmlns="" xmlns:ma14="http://schemas.microsoft.com/office/mac/drawingml/2011/main" val="1"/>
             </a:ext>
           </a:extLst>
         </p:spPr>
@@ -28801,7 +28801,7 @@
           </a:ln>
           <a:extLst>
             <a:ext uri="{C572A759-6A51-4108-AA02-DFA0A04FC94B}">
-              <ma14:wrappingTextBoxFlag xmlns:ma14="http://schemas.microsoft.com/office/mac/drawingml/2011/main" xmlns="" val="1"/>
+              <ma14:wrappingTextBoxFlag xmlns="" xmlns:ma14="http://schemas.microsoft.com/office/mac/drawingml/2011/main" val="1"/>
             </a:ext>
           </a:extLst>
         </p:spPr>
@@ -28893,7 +28893,7 @@
           </a:ln>
           <a:extLst>
             <a:ext uri="{C572A759-6A51-4108-AA02-DFA0A04FC94B}">
-              <ma14:wrappingTextBoxFlag xmlns:ma14="http://schemas.microsoft.com/office/mac/drawingml/2011/main" xmlns="" val="1"/>
+              <ma14:wrappingTextBoxFlag xmlns="" xmlns:ma14="http://schemas.microsoft.com/office/mac/drawingml/2011/main" val="1"/>
             </a:ext>
           </a:extLst>
         </p:spPr>
@@ -30756,7 +30756,7 @@
           </a:ln>
           <a:extLst>
             <a:ext uri="{C572A759-6A51-4108-AA02-DFA0A04FC94B}">
-              <ma14:wrappingTextBoxFlag xmlns:ma14="http://schemas.microsoft.com/office/mac/drawingml/2011/main" xmlns="" val="1"/>
+              <ma14:wrappingTextBoxFlag xmlns="" xmlns:ma14="http://schemas.microsoft.com/office/mac/drawingml/2011/main" val="1"/>
             </a:ext>
           </a:extLst>
         </p:spPr>
@@ -31913,7 +31913,7 @@
           </a:ln>
           <a:extLst>
             <a:ext uri="{C572A759-6A51-4108-AA02-DFA0A04FC94B}">
-              <ma14:wrappingTextBoxFlag xmlns:ma14="http://schemas.microsoft.com/office/mac/drawingml/2011/main" xmlns="" val="1"/>
+              <ma14:wrappingTextBoxFlag xmlns="" xmlns:ma14="http://schemas.microsoft.com/office/mac/drawingml/2011/main" val="1"/>
             </a:ext>
           </a:extLst>
         </p:spPr>
@@ -32060,7 +32060,7 @@
           </a:ln>
           <a:extLst>
             <a:ext uri="{C572A759-6A51-4108-AA02-DFA0A04FC94B}">
-              <ma14:wrappingTextBoxFlag xmlns:ma14="http://schemas.microsoft.com/office/mac/drawingml/2011/main" xmlns="" val="1"/>
+              <ma14:wrappingTextBoxFlag xmlns="" xmlns:ma14="http://schemas.microsoft.com/office/mac/drawingml/2011/main" val="1"/>
             </a:ext>
           </a:extLst>
         </p:spPr>
@@ -32292,7 +32292,7 @@
           </a:ln>
           <a:extLst>
             <a:ext uri="{C572A759-6A51-4108-AA02-DFA0A04FC94B}">
-              <ma14:wrappingTextBoxFlag xmlns:ma14="http://schemas.microsoft.com/office/mac/drawingml/2011/main" xmlns="" val="1"/>
+              <ma14:wrappingTextBoxFlag xmlns="" xmlns:ma14="http://schemas.microsoft.com/office/mac/drawingml/2011/main" val="1"/>
             </a:ext>
           </a:extLst>
         </p:spPr>
@@ -32376,7 +32376,7 @@
           </a:ln>
           <a:extLst>
             <a:ext uri="{C572A759-6A51-4108-AA02-DFA0A04FC94B}">
-              <ma14:wrappingTextBoxFlag xmlns:ma14="http://schemas.microsoft.com/office/mac/drawingml/2011/main" xmlns="" val="1"/>
+              <ma14:wrappingTextBoxFlag xmlns="" xmlns:ma14="http://schemas.microsoft.com/office/mac/drawingml/2011/main" val="1"/>
             </a:ext>
           </a:extLst>
         </p:spPr>
@@ -33415,7 +33415,7 @@
           </a:ln>
           <a:extLst>
             <a:ext uri="{C572A759-6A51-4108-AA02-DFA0A04FC94B}">
-              <ma14:wrappingTextBoxFlag xmlns:ma14="http://schemas.microsoft.com/office/mac/drawingml/2011/main" xmlns="" val="1"/>
+              <ma14:wrappingTextBoxFlag xmlns="" xmlns:ma14="http://schemas.microsoft.com/office/mac/drawingml/2011/main" val="1"/>
             </a:ext>
           </a:extLst>
         </p:spPr>
@@ -34927,7 +34927,7 @@
           </a:ln>
           <a:extLst>
             <a:ext uri="{C572A759-6A51-4108-AA02-DFA0A04FC94B}">
-              <ma14:wrappingTextBoxFlag xmlns:ma14="http://schemas.microsoft.com/office/mac/drawingml/2011/main" xmlns="" val="1"/>
+              <ma14:wrappingTextBoxFlag xmlns="" xmlns:ma14="http://schemas.microsoft.com/office/mac/drawingml/2011/main" val="1"/>
             </a:ext>
           </a:extLst>
         </p:spPr>
@@ -36956,7 +36956,7 @@
           </a:ln>
           <a:extLst>
             <a:ext uri="{C572A759-6A51-4108-AA02-DFA0A04FC94B}">
-              <ma14:wrappingTextBoxFlag xmlns:ma14="http://schemas.microsoft.com/office/mac/drawingml/2011/main" xmlns="" val="1"/>
+              <ma14:wrappingTextBoxFlag xmlns="" xmlns:ma14="http://schemas.microsoft.com/office/mac/drawingml/2011/main" val="1"/>
             </a:ext>
           </a:extLst>
         </p:spPr>
@@ -37159,7 +37159,7 @@
                   <a:srgbClr val="5B6167"/>
                 </a:solidFill>
               </a:rPr>
-              <a:t>25</a:t>
+              <a:t>26</a:t>
             </a:r>
             <a:r>
               <a:rPr dirty="0">

</xml_diff>